<commit_message>
docs: update vanilla live URL to https://ecocycle-vanilla.vercel.app/
</commit_message>
<xml_diff>
--- a/EcoCycle_Project_Presentation.pptx
+++ b/EcoCycle_Project_Presentation.pptx
@@ -5491,7 +5491,7 @@
                   <a:srgbClr val="334155"/>
                 </a:solidFill>
               </a:rPr>
-              <a:t> https://chandan-bk.github.io/ecocycle-vanilla/</a:t>
+              <a:t> https://ecocycle-vanilla.vercel.app/</a:t>
             </a:r>
           </a:p>
           <a:p>
@@ -5507,7 +5507,7 @@
               </a:defRPr>
             </a:pPr>
             <a:r>
-              <a:t>HOSTED ON GITHUB PAGES</a:t>
+              <a:t>HOSTED ON VERCEL CLOUD</a:t>
             </a:r>
           </a:p>
           <a:p>
@@ -5551,7 +5551,7 @@
                   <a:srgbClr val="334155"/>
                 </a:solidFill>
               </a:rPr>
-              <a:t>• Zero-build architecture; instant loading directly from GitHub master branch.</a:t>
+              <a:t>• Zero-build architecture; instant global edge deployment on Vercel.</a:t>
             </a:r>
           </a:p>
           <a:p>
@@ -7534,7 +7534,7 @@
               </a:defRPr>
             </a:pPr>
             <a:r>
-              <a:t>🌿 Vanilla Edition Live Demo:   https://chandan-bk.github.io/ecocycle-vanilla/</a:t>
+              <a:t>🌿 Vanilla Edition Live Demo:   https://ecocycle-vanilla.vercel.app/</a:t>
             </a:r>
           </a:p>
           <a:p>
@@ -12513,7 +12513,7 @@
                   <a:srgbClr val="334155"/>
                 </a:solidFill>
               </a:rPr>
-              <a:t> Hosted on GitHub Pages directly from repository root.</a:t>
+              <a:t> Hosted on Vercel Cloud (https://ecocycle-vanilla.vercel.app/).</a:t>
             </a:r>
           </a:p>
         </p:txBody>
@@ -13819,7 +13819,7 @@
                   <a:srgbClr val="334155"/>
                 </a:solidFill>
               </a:rPr>
-              <a:t>• Vercel Edge Network (React) &amp; GitHub Pages CDN (Pure Vanilla Web)</a:t>
+              <a:t>• Vercel Cloud Edge Network (Both React &amp; Vanilla Editions)</a:t>
             </a:r>
           </a:p>
         </p:txBody>

</xml_diff>

<commit_message>
docs: remove viva references, update author to Chandan B K (2nd Sem CSE), and refresh presentation
</commit_message>
<xml_diff>
--- a/EcoCycle_Project_Presentation.pptx
+++ b/EcoCycle_Project_Presentation.pptx
@@ -3219,7 +3219,7 @@
               </a:defRPr>
             </a:pPr>
             <a:r>
-              <a:t>🌱 FINAL YEAR CAPSTONE PROJECT PRESENTATION</a:t>
+              <a:t>🌱 SUSTAINABLE E-WASTE MANAGEMENT PLATFORM</a:t>
             </a:r>
           </a:p>
         </p:txBody>
@@ -3399,7 +3399,7 @@
               </a:defRPr>
             </a:pPr>
             <a:r>
-              <a:t>• Chandan B K  (Lead &amp; Full-Stack Architect)</a:t>
+              <a:t>• Chandan B K  (Lead Architect — 2nd Sem CSE)</a:t>
             </a:r>
           </a:p>
           <a:p>
@@ -3486,7 +3486,7 @@
               </a:defRPr>
             </a:pPr>
             <a:r>
-              <a:t>ACADEMIC DETAILS:</a:t>
+              <a:t>PROJECT AUTHOR &amp; ACADEMICS:</a:t>
             </a:r>
           </a:p>
           <a:p>
@@ -3502,6 +3502,22 @@
               </a:defRPr>
             </a:pPr>
             <a:r>
+              <a:t>Author: Chandan B K (2nd Semester CSE Student)</a:t>
+            </a:r>
+          </a:p>
+          <a:p>
+            <a:pPr>
+              <a:spcAft>
+                <a:spcPts val="300"/>
+              </a:spcAft>
+              <a:defRPr sz="1200">
+                <a:solidFill>
+                  <a:srgbClr val="CBD5E1"/>
+                </a:solidFill>
+                <a:latin typeface="Segoe UI"/>
+              </a:defRPr>
+            </a:pPr>
+            <a:r>
               <a:t>Department of Computer Science &amp; Engineering</a:t>
             </a:r>
           </a:p>
@@ -3519,22 +3535,6 @@
             </a:pPr>
             <a:r>
               <a:t>Project Guide: Prof. [Guide Name / Designation]</a:t>
-            </a:r>
-          </a:p>
-          <a:p>
-            <a:pPr>
-              <a:spcAft>
-                <a:spcPts val="300"/>
-              </a:spcAft>
-              <a:defRPr sz="1200">
-                <a:solidFill>
-                  <a:srgbClr val="CBD5E1"/>
-                </a:solidFill>
-                <a:latin typeface="Segoe UI"/>
-              </a:defRPr>
-            </a:pPr>
-            <a:r>
-              <a:t>Institution: [Your College / University Name]</a:t>
             </a:r>
           </a:p>
           <a:p>
@@ -7982,7 +7982,7 @@
               </a:defRPr>
             </a:pPr>
             <a:r>
-              <a:t>Team Lead &amp; Full-Stack Architect</a:t>
+              <a:t>Lead &amp; Full-Stack Architect (2nd Sem CSE)</a:t>
             </a:r>
           </a:p>
           <a:p>
@@ -9198,7 +9198,7 @@
                   <a:srgbClr val="334155"/>
                 </a:solidFill>
               </a:rPr>
-              <a:t>• System Testing, Documentation &amp; Viva Preparation</a:t>
+              <a:t>• System Testing, Comprehensive Documentation &amp; User Guides</a:t>
             </a:r>
           </a:p>
         </p:txBody>
@@ -12725,7 +12725,7 @@
                   <a:srgbClr val="0F172A"/>
                 </a:solidFill>
               </a:rPr>
-              <a:t>• Viva Defense Advantage:</a:t>
+              <a:t>• Architectural Advantage:</a:t>
             </a:r>
             <a:r>
               <a:rPr>

</xml_diff>

<commit_message>
feat(presentation): upgrade presentation deck with 16:9 stage scaling, team roster, and speaker notes
</commit_message>
<xml_diff>
--- a/EcoCycle_Project_Presentation.pptx
+++ b/EcoCycle_Project_Presentation.pptx
@@ -3399,7 +3399,7 @@
               </a:defRPr>
             </a:pPr>
             <a:r>
-              <a:t>• Chandan B K  (Lead Architect — 2nd Sem CSE)</a:t>
+              <a:t>• Chandan B K  (Lead Architect · 2nd Sem CSE)</a:t>
             </a:r>
           </a:p>
           <a:p>
@@ -3415,7 +3415,7 @@
               </a:defRPr>
             </a:pPr>
             <a:r>
-              <a:t>• Team Member 2  (Frontend &amp; Leaflet GIS Specialist)</a:t>
+              <a:t>• Dhanush Gowda R  (Frontend &amp; Leaflet GIS · 2nd Sem CSE)</a:t>
             </a:r>
           </a:p>
           <a:p>
@@ -3431,7 +3431,7 @@
               </a:defRPr>
             </a:pPr>
             <a:r>
-              <a:t>• Team Member 3  (Backend &amp; EmailJS Systems Engineer)</a:t>
+              <a:t>• Dore Prasad C K  (Backend &amp; EmailJS Systems · 2nd Sem CSE)</a:t>
             </a:r>
           </a:p>
           <a:p>
@@ -3447,7 +3447,7 @@
               </a:defRPr>
             </a:pPr>
             <a:r>
-              <a:t>• Team Member 4  (Data Analytics &amp; Environmental Modeling)</a:t>
+              <a:t>• Gowri Shankar S  (Data Analytics &amp; QA · 2nd Sem CSE)</a:t>
             </a:r>
           </a:p>
         </p:txBody>
@@ -3486,7 +3486,7 @@
               </a:defRPr>
             </a:pPr>
             <a:r>
-              <a:t>PROJECT AUTHOR &amp; ACADEMICS:</a:t>
+              <a:t>INSTITUTION &amp; PROGRAM:</a:t>
             </a:r>
           </a:p>
           <a:p>
@@ -3502,7 +3502,7 @@
               </a:defRPr>
             </a:pPr>
             <a:r>
-              <a:t>Author: Chandan B K (2nd Semester CSE Student)</a:t>
+              <a:t>Dept. of Computer Science &amp; Engineering</a:t>
             </a:r>
           </a:p>
           <a:p>
@@ -3518,7 +3518,7 @@
               </a:defRPr>
             </a:pPr>
             <a:r>
-              <a:t>Department of Computer Science &amp; Engineering</a:t>
+              <a:t>PES College of Engineering, Mandya</a:t>
             </a:r>
           </a:p>
           <a:p>
@@ -3534,7 +3534,7 @@
               </a:defRPr>
             </a:pPr>
             <a:r>
-              <a:t>Project Guide: Prof. [Guide Name / Designation]</a:t>
+              <a:t>5-Day Skill Development Program (12–16 Oct 2026)</a:t>
             </a:r>
           </a:p>
           <a:p>
@@ -3550,7 +3550,7 @@
               </a:defRPr>
             </a:pPr>
             <a:r>
-              <a:t>Academic Year: 2025 – 2026</a:t>
+              <a:t>In Collaboration with ExcelR Edtech Pvt. Ltd.</a:t>
             </a:r>
           </a:p>
         </p:txBody>
@@ -7614,7 +7614,7 @@
               </a:defRPr>
             </a:pPr>
             <a:r>
-              <a:t>👥 Team Contact:                 Chandan B K &amp; Capstone Project Team (4 Members)</a:t>
+              <a:t>👥 Team Members:                 Chandan B K, Dhanush Gowda R, Dore Prasad C K, Gowri Shankar S (PESCE)</a:t>
             </a:r>
           </a:p>
         </p:txBody>
@@ -7982,7 +7982,7 @@
               </a:defRPr>
             </a:pPr>
             <a:r>
-              <a:t>Lead &amp; Full-Stack Architect (2nd Sem CSE)</a:t>
+              <a:t>Lead &amp; Full-Stack Architect (2nd Sem CSE · PESCE)</a:t>
             </a:r>
           </a:p>
           <a:p>
@@ -7995,7 +7995,7 @@
               </a:defRPr>
             </a:pPr>
             <a:r>
-              <a:t>USN: [Your USN / Roll No]</a:t>
+              <a:t>Dept. of CSE, PESCE</a:t>
             </a:r>
           </a:p>
         </p:txBody>
@@ -8286,7 +8286,7 @@
               </a:defRPr>
             </a:pPr>
             <a:r>
-              <a:t>Team Member 2</a:t>
+              <a:t>Dhanush Gowda R</a:t>
             </a:r>
           </a:p>
         </p:txBody>
@@ -8325,7 +8325,7 @@
               </a:defRPr>
             </a:pPr>
             <a:r>
-              <a:t>Frontend &amp; UI/UX Specialist</a:t>
+              <a:t>Frontend &amp; Leaflet GIS (2nd Sem CSE · PESCE)</a:t>
             </a:r>
           </a:p>
           <a:p>
@@ -8338,7 +8338,7 @@
               </a:defRPr>
             </a:pPr>
             <a:r>
-              <a:t>USN: [Member 2 USN / Roll No]</a:t>
+              <a:t>Dept. of CSE, PESCE</a:t>
             </a:r>
           </a:p>
         </p:txBody>
@@ -8629,7 +8629,7 @@
               </a:defRPr>
             </a:pPr>
             <a:r>
-              <a:t>Team Member 3</a:t>
+              <a:t>Dore Prasad C K</a:t>
             </a:r>
           </a:p>
         </p:txBody>
@@ -8668,7 +8668,7 @@
               </a:defRPr>
             </a:pPr>
             <a:r>
-              <a:t>Backend &amp; Integration Engineer</a:t>
+              <a:t>Backend &amp; EmailJS Systems (2nd Sem CSE · PESCE)</a:t>
             </a:r>
           </a:p>
           <a:p>
@@ -8681,7 +8681,7 @@
               </a:defRPr>
             </a:pPr>
             <a:r>
-              <a:t>USN: [Member 3 USN / Roll No]</a:t>
+              <a:t>Dept. of CSE, PESCE</a:t>
             </a:r>
           </a:p>
         </p:txBody>
@@ -8972,7 +8972,7 @@
               </a:defRPr>
             </a:pPr>
             <a:r>
-              <a:t>Team Member 4</a:t>
+              <a:t>Gowri Shankar S</a:t>
             </a:r>
           </a:p>
         </p:txBody>
@@ -9011,7 +9011,7 @@
               </a:defRPr>
             </a:pPr>
             <a:r>
-              <a:t>Data Analyst &amp; Environmental Modeler</a:t>
+              <a:t>Analytics &amp; QA Modeler (2nd Sem CSE · PESCE)</a:t>
             </a:r>
           </a:p>
           <a:p>
@@ -9024,7 +9024,7 @@
               </a:defRPr>
             </a:pPr>
             <a:r>
-              <a:t>USN: [Member 4 USN / Roll No]</a:t>
+              <a:t>Dept. of CSE, PESCE</a:t>
             </a:r>
           </a:p>
         </p:txBody>

</xml_diff>

<commit_message>
docs(presentation): restrict presentation deck strictly to pure vanilla web stack
</commit_message>
<xml_diff>
--- a/EcoCycle_Project_Presentation.pptx
+++ b/EcoCycle_Project_Presentation.pptx
@@ -4607,7 +4607,7 @@
                   <a:srgbClr val="0F172A"/>
                 </a:solidFill>
               </a:rPr>
-              <a:t>• Unified Infrastructure:</a:t>
+              <a:t>• Direct Client Dispatch:</a:t>
             </a:r>
             <a:r>
               <a:rPr>
@@ -4615,7 +4615,7 @@
                   <a:srgbClr val="334155"/>
                 </a:solidFill>
               </a:rPr>
-              <a:t> Shared service (`service_np1cnlg`) and template (`template_to9738m`) used across both React &amp; Vanilla projects.</a:t>
+              <a:t> Pre-configured service (`service_np1cnlg`) and template (`template_to9738m`) dispatching securely from the browser.</a:t>
             </a:r>
           </a:p>
           <a:p>
@@ -5177,7 +5177,7 @@
               </a:defRPr>
             </a:pPr>
             <a:r>
-              <a:t>Live Cloud Deployments &amp; Cross-Platform Parity</a:t>
+              <a:t>Live Cloud Deployments &amp; Empirical Validation</a:t>
             </a:r>
           </a:p>
         </p:txBody>
@@ -5213,7 +5213,7 @@
               </a:defRPr>
             </a:pPr>
             <a:r>
-              <a:t>Both editions successfully tested, cloud-hosted, and live on production endpoints</a:t>
+              <a:t>Zero-build vanilla web architecture verified and live on public cloud endpoints</a:t>
             </a:r>
           </a:p>
         </p:txBody>
@@ -5291,13 +5291,13 @@
               </a:spcAft>
               <a:defRPr sz="1100" b="1">
                 <a:solidFill>
-                  <a:srgbClr val="0EA5E9"/>
-                </a:solidFill>
-                <a:latin typeface="Segoe UI"/>
-              </a:defRPr>
-            </a:pPr>
-            <a:r>
-              <a:t>🚀 Project 1: React Full-Stack Edition</a:t>
+                  <a:srgbClr val="10A34A"/>
+                </a:solidFill>
+                <a:latin typeface="Segoe UI"/>
+              </a:defRPr>
+            </a:pPr>
+            <a:r>
+              <a:t>🌿 Primary: Vercel Cloud Edge</a:t>
             </a:r>
             <a:r>
               <a:rPr b="1">
@@ -5305,7 +5305,7 @@
                   <a:srgbClr val="0F172A"/>
                 </a:solidFill>
               </a:rPr>
-              <a:t>• Live URL:</a:t>
+              <a:t>• Live Production URL:</a:t>
             </a:r>
             <a:r>
               <a:rPr>
@@ -5313,7 +5313,7 @@
                   <a:srgbClr val="334155"/>
                 </a:solidFill>
               </a:rPr>
-              <a:t> https://ecocycle-beryl.vercel.app/</a:t>
+              <a:t> https://ecocycle-vanilla.vercel.app/</a:t>
             </a:r>
           </a:p>
           <a:p>
@@ -5329,7 +5329,7 @@
               </a:defRPr>
             </a:pPr>
             <a:r>
-              <a:t>HOSTED ON VERCEL GLOBAL EDGE</a:t>
+              <a:t>PRODUCTION EDGE NETWORK</a:t>
             </a:r>
           </a:p>
           <a:p>
@@ -5347,7 +5347,7 @@
                   <a:srgbClr val="0F172A"/>
                 </a:solidFill>
               </a:rPr>
-              <a:t>• Repository:</a:t>
+              <a:t>• Continuous Deployment:</a:t>
             </a:r>
             <a:r>
               <a:rPr>
@@ -5355,7 +5355,7 @@
                   <a:srgbClr val="334155"/>
                 </a:solidFill>
               </a:rPr>
-              <a:t> https://github.com/chandan-bk/ecocycle</a:t>
+              <a:t> Automated CI/CD pipeline linked to GitHub `main`.</a:t>
             </a:r>
           </a:p>
           <a:p>
@@ -5373,7 +5373,7 @@
                   <a:srgbClr val="334155"/>
                 </a:solidFill>
               </a:rPr>
-              <a:t>• Lighthouse Performance: 98/100; First Contentful Paint &lt; 0.8s.</a:t>
+              <a:t>• Lighthouse Score: 99/100 performance; First Contentful Paint &lt; 0.4s.</a:t>
             </a:r>
           </a:p>
           <a:p>
@@ -5391,7 +5391,7 @@
                   <a:srgbClr val="334155"/>
                 </a:solidFill>
               </a:rPr>
-              <a:t>• SPA client routing with real-time Supabase Auth state synchronization.</a:t>
+              <a:t>• Instant global edge caching with SSL/TLS encryption by default.</a:t>
             </a:r>
           </a:p>
         </p:txBody>
@@ -5469,13 +5469,13 @@
               </a:spcAft>
               <a:defRPr sz="1100" b="1">
                 <a:solidFill>
-                  <a:srgbClr val="10A34A"/>
-                </a:solidFill>
-                <a:latin typeface="Segoe UI"/>
-              </a:defRPr>
-            </a:pPr>
-            <a:r>
-              <a:t>🌿 Project 2: Pure Vanilla Web Edition</a:t>
+                  <a:srgbClr val="0D9488"/>
+                </a:solidFill>
+                <a:latin typeface="Segoe UI"/>
+              </a:defRPr>
+            </a:pPr>
+            <a:r>
+              <a:t>🌐 Mirror: GitHub Pages Static Host</a:t>
             </a:r>
             <a:r>
               <a:rPr b="1">
@@ -5483,7 +5483,7 @@
                   <a:srgbClr val="0F172A"/>
                 </a:solidFill>
               </a:rPr>
-              <a:t>• Live URL:</a:t>
+              <a:t>• Live Mirror URL:</a:t>
             </a:r>
             <a:r>
               <a:rPr>
@@ -5491,7 +5491,7 @@
                   <a:srgbClr val="334155"/>
                 </a:solidFill>
               </a:rPr>
-              <a:t> https://ecocycle-vanilla.vercel.app/</a:t>
+              <a:t> https://chandan-bk.github.io/ecocycle-vanilla/</a:t>
             </a:r>
           </a:p>
           <a:p>
@@ -5507,7 +5507,7 @@
               </a:defRPr>
             </a:pPr>
             <a:r>
-              <a:t>HOSTED ON VERCEL CLOUD</a:t>
+              <a:t>HIGH-AVAILABILITY CLOUD MIRROR</a:t>
             </a:r>
           </a:p>
           <a:p>
@@ -5525,7 +5525,7 @@
                   <a:srgbClr val="0F172A"/>
                 </a:solidFill>
               </a:rPr>
-              <a:t>• Repository:</a:t>
+              <a:t>• Source Repository:</a:t>
             </a:r>
             <a:r>
               <a:rPr>
@@ -5551,7 +5551,7 @@
                   <a:srgbClr val="334155"/>
                 </a:solidFill>
               </a:rPr>
-              <a:t>• Zero-build architecture; instant global edge deployment on Vercel.</a:t>
+              <a:t>• Zero build tools; native browser static file serving directly from Git.</a:t>
             </a:r>
           </a:p>
           <a:p>
@@ -5569,7 +5569,7 @@
                   <a:srgbClr val="334155"/>
                 </a:solidFill>
               </a:rPr>
-              <a:t>• Verified identical operational parity with unified Supabase database.</a:t>
+              <a:t>• Full client functionality: Supabase Auth, Leaflet GIS, and EmailJS alerts.</a:t>
             </a:r>
           </a:p>
         </p:txBody>
@@ -5669,7 +5669,7 @@
                   <a:srgbClr val="334155"/>
                 </a:solidFill>
               </a:rPr>
-              <a:t> User schedules pickup in Vanilla web -&gt; Confirmed in DB -&gt; Instant Email receipt received -&gt; Visible in React 'My Pickups'. [PASSED]</a:t>
+              <a:t> User schedules pickup in web portal -&gt; Confirmed in DB -&gt; Instant Email receipt received -&gt; Visible in 'My Pickups'. [PASSED]</a:t>
             </a:r>
           </a:p>
           <a:p>
@@ -7069,7 +7069,7 @@
                   <a:srgbClr val="334155"/>
                 </a:solidFill>
               </a:rPr>
-              <a:t>• Demonstrated competence in both modern reactive frameworks (React + Vite) and pure web standards (HTML5/CSS3/ES6+).</a:t>
+              <a:t>• Proved that enterprise-grade cloud applications can be built with pure HTML5, CSS3, and ES6+.</a:t>
             </a:r>
           </a:p>
           <a:p>
@@ -7085,7 +7085,7 @@
               </a:defRPr>
             </a:pPr>
             <a:r>
-              <a:t>DUAL-STACK ENGINEERING</a:t>
+              <a:t>PURE VANILLA ENGINEERING</a:t>
             </a:r>
           </a:p>
           <a:p>
@@ -7103,7 +7103,7 @@
                   <a:srgbClr val="334155"/>
                 </a:solidFill>
               </a:rPr>
-              <a:t>• Proved that pure vanilla code achieves parity with zero build dependencies.</a:t>
+              <a:t>• Eliminated build-tool complexity (zero node_modules, zero bundlers, instant execution).</a:t>
             </a:r>
           </a:p>
           <a:p>
@@ -7121,7 +7121,7 @@
                   <a:srgbClr val="334155"/>
                 </a:solidFill>
               </a:rPr>
-              <a:t>• Leveraged BaaS (Supabase) to eliminate backend infrastructure management.</a:t>
+              <a:t>• Leveraged BaaS (Supabase) to eliminate backend infrastructure management while enforcing RLS.</a:t>
             </a:r>
           </a:p>
         </p:txBody>
@@ -7308,7 +7308,7 @@
                   <a:srgbClr val="334155"/>
                 </a:solidFill>
               </a:rPr>
-              <a:t>• Both projects successfully deployed and validated on public production URLs.</a:t>
+              <a:t>• Platform successfully deployed and validated on public production URLs (Vercel &amp; GitHub Pages).</a:t>
             </a:r>
           </a:p>
         </p:txBody>
@@ -7418,7 +7418,7 @@
               </a:defRPr>
             </a:pPr>
             <a:r>
-              <a:t>Questions &amp; Academic Discussion Welcome</a:t>
+              <a:t>Questions &amp; Technical Discussion Welcome</a:t>
             </a:r>
           </a:p>
         </p:txBody>
@@ -7518,7 +7518,7 @@
               </a:defRPr>
             </a:pPr>
             <a:r>
-              <a:t>🌐 React Edition Live Demo:     https://ecocycle-beryl.vercel.app/</a:t>
+              <a:t>🌿 Production Web App (Vercel):  https://ecocycle-vanilla.vercel.app/</a:t>
             </a:r>
           </a:p>
           <a:p>
@@ -7534,7 +7534,7 @@
               </a:defRPr>
             </a:pPr>
             <a:r>
-              <a:t>🌿 Vanilla Edition Live Demo:   https://ecocycle-vanilla.vercel.app/</a:t>
+              <a:t>🌐 Live Static Mirror (GitHub):  https://chandan-bk.github.io/ecocycle-vanilla/</a:t>
             </a:r>
           </a:p>
           <a:p>
@@ -7550,7 +7550,7 @@
               </a:defRPr>
             </a:pPr>
             <a:r>
-              <a:t>📦 React GitHub Repository:      https://github.com/chandan-bk/ecocycle</a:t>
+              <a:t>📦 Source Code (GitHub):        https://github.com/chandan-bk/ecocycle-vanilla</a:t>
             </a:r>
           </a:p>
           <a:p>
@@ -7566,7 +7566,7 @@
               </a:defRPr>
             </a:pPr>
             <a:r>
-              <a:t>📦 Vanilla GitHub Repository:    https://github.com/chandan-bk/ecocycle-vanilla</a:t>
+              <a:t>🗄️ Supabase Cloud Database:      https://anusmzkuuudrtgzgccby.supabase.co</a:t>
             </a:r>
           </a:p>
           <a:p>
@@ -7582,7 +7582,7 @@
               </a:defRPr>
             </a:pPr>
             <a:r>
-              <a:t>🗄️ Supabase Cloud DB Host:       https://anusmzkuuudrtgzgccby.supabase.co</a:t>
+              <a:t>✉️ EmailJS Notification Engine:  service_np1cnlg (template_to9738m)</a:t>
             </a:r>
           </a:p>
           <a:p>
@@ -7598,23 +7598,7 @@
               </a:defRPr>
             </a:pPr>
             <a:r>
-              <a:t>✉️ EmailJS Service Engine:       service_np1cnlg (template_to9738m)</a:t>
-            </a:r>
-          </a:p>
-          <a:p>
-            <a:pPr>
-              <a:spcAft>
-                <a:spcPts val="400"/>
-              </a:spcAft>
-              <a:defRPr sz="1200">
-                <a:solidFill>
-                  <a:srgbClr val="F1F5F9"/>
-                </a:solidFill>
-                <a:latin typeface="Consolas"/>
-              </a:defRPr>
-            </a:pPr>
-            <a:r>
-              <a:t>👥 Team Members:                 Chandan B K, Dhanush Gowda R, Dore Prasad C K, Gowri Shankar S (PESCE)</a:t>
+              <a:t>👥 Team Members (PESCE CSE):     Chandan B K, Dhanush Gowda R, Dore Prasad C K, Gowri Shankar S</a:t>
             </a:r>
           </a:p>
         </p:txBody>
@@ -8169,7 +8153,7 @@
                   <a:srgbClr val="334155"/>
                 </a:solidFill>
               </a:rPr>
-              <a:t>• Cross-edition parity (React SPA &amp; Pure Vanilla Web)</a:t>
+              <a:t>• Modular Vanilla ES6+ State &amp; Session Synchronization</a:t>
             </a:r>
           </a:p>
         </p:txBody>
@@ -12001,7 +11985,7 @@
               </a:defRPr>
             </a:pPr>
             <a:r>
-              <a:t>ARCHITECTURAL INNOVATION</a:t>
+              <a:t>FRONTEND ENGINEERING</a:t>
             </a:r>
           </a:p>
         </p:txBody>
@@ -12037,7 +12021,7 @@
               </a:defRPr>
             </a:pPr>
             <a:r>
-              <a:t>Dual-Implementation Strategy: React SPA &amp; Pure Vanilla Web</a:t>
+              <a:t>Pure Vanilla Web Architecture: Zero-Framework Mastery</a:t>
             </a:r>
           </a:p>
         </p:txBody>
@@ -12073,7 +12057,7 @@
               </a:defRPr>
             </a:pPr>
             <a:r>
-              <a:t>Demonstrating both modern component frameworks and zero-dependency web standards</a:t>
+              <a:t>High performance, zero build overhead, and maximum web standards compliance</a:t>
             </a:r>
           </a:p>
         </p:txBody>
@@ -12151,13 +12135,13 @@
               </a:spcAft>
               <a:defRPr sz="1200" b="1">
                 <a:solidFill>
-                  <a:srgbClr val="0EA5E9"/>
-                </a:solidFill>
-                <a:latin typeface="Segoe UI"/>
-              </a:defRPr>
-            </a:pPr>
-            <a:r>
-              <a:t>⚛️ React Modern SPA</a:t>
+                  <a:srgbClr val="064E3B"/>
+                </a:solidFill>
+                <a:latin typeface="Segoe UI"/>
+              </a:defRPr>
+            </a:pPr>
+            <a:r>
+              <a:t>🌐 HTML5 Semantic Core</a:t>
             </a:r>
             <a:r>
               <a:rPr b="1">
@@ -12165,7 +12149,7 @@
                   <a:srgbClr val="0F172A"/>
                 </a:solidFill>
               </a:rPr>
-              <a:t>• React 18 &amp; Vite:</a:t>
+              <a:t>• 8 Semantic Pages:</a:t>
             </a:r>
             <a:r>
               <a:rPr>
@@ -12173,7 +12157,7 @@
                   <a:srgbClr val="334155"/>
                 </a:solidFill>
               </a:rPr>
-              <a:t> Ultra-fast HMR and optimized asset bundling.</a:t>
+              <a:t> Dedicated views for Locator, Pickup, Tracking, Quiz, Analytics, and Admin.</a:t>
             </a:r>
           </a:p>
           <a:p>
@@ -12189,7 +12173,7 @@
               </a:defRPr>
             </a:pPr>
             <a:r>
-              <a:t>ENTERPRISE COMPONENT ARCHITECTURE</a:t>
+              <a:t>ACCESSIBLE &amp; MODULAR MARKUP</a:t>
             </a:r>
           </a:p>
           <a:p>
@@ -12207,7 +12191,7 @@
                   <a:srgbClr val="0F172A"/>
                 </a:solidFill>
               </a:rPr>
-              <a:t>• Tailwind CSS:</a:t>
+              <a:t>• Native Validation:</a:t>
             </a:r>
             <a:r>
               <a:rPr>
@@ -12215,7 +12199,7 @@
                   <a:srgbClr val="334155"/>
                 </a:solidFill>
               </a:rPr>
-              <a:t> Utility-first styling with modern design system.</a:t>
+              <a:t> HTML5 constraint validation for dates, email addresses, and quantities.</a:t>
             </a:r>
           </a:p>
           <a:p>
@@ -12233,7 +12217,7 @@
                   <a:srgbClr val="0F172A"/>
                 </a:solidFill>
               </a:rPr>
-              <a:t>• Lucide React:</a:t>
+              <a:t>• Accessible Landmarks:</a:t>
             </a:r>
             <a:r>
               <a:rPr>
@@ -12241,7 +12225,7 @@
                   <a:srgbClr val="334155"/>
                 </a:solidFill>
               </a:rPr>
-              <a:t> Consistent SVG iconography across all components.</a:t>
+              <a:t> Built with `&lt;main&gt;`, `&lt;nav&gt;`, `&lt;header&gt;`, `&lt;footer&gt;`, and `&lt;section&gt;` tags.</a:t>
             </a:r>
           </a:p>
           <a:p>
@@ -12259,7 +12243,7 @@
                   <a:srgbClr val="0F172A"/>
                 </a:solidFill>
               </a:rPr>
-              <a:t>• Client-Side Routing:</a:t>
+              <a:t>• Fastest First Paint:</a:t>
             </a:r>
             <a:r>
               <a:rPr>
@@ -12267,7 +12251,7 @@
                   <a:srgbClr val="334155"/>
                 </a:solidFill>
               </a:rPr>
-              <a:t> Seamless React Router DOM navigation.</a:t>
+              <a:t> Zero virtual DOM diffing; browser renders HTML directly on arrival.</a:t>
             </a:r>
           </a:p>
           <a:p>
@@ -12285,7 +12269,7 @@
                   <a:srgbClr val="0F172A"/>
                 </a:solidFill>
               </a:rPr>
-              <a:t>• Live Deployment:</a:t>
+              <a:t>• Zero Transpilation:</a:t>
             </a:r>
             <a:r>
               <a:rPr>
@@ -12293,7 +12277,7 @@
                   <a:srgbClr val="334155"/>
                 </a:solidFill>
               </a:rPr>
-              <a:t> Hosted on Vercel Global Edge CDN.</a:t>
+              <a:t> Works instantly across modern desktop and mobile browsers.</a:t>
             </a:r>
           </a:p>
         </p:txBody>
@@ -12377,7 +12361,7 @@
               </a:defRPr>
             </a:pPr>
             <a:r>
-              <a:t>🌿 Pure Vanilla Edition</a:t>
+              <a:t>🎨 Custom CSS3 System</a:t>
             </a:r>
             <a:r>
               <a:rPr b="1">
@@ -12385,7 +12369,7 @@
                   <a:srgbClr val="0F172A"/>
                 </a:solidFill>
               </a:rPr>
-              <a:t>• Standard HTML5 &amp; CSS3:</a:t>
+              <a:t>• CSS Custom Properties:</a:t>
             </a:r>
             <a:r>
               <a:rPr>
@@ -12393,7 +12377,7 @@
                   <a:srgbClr val="334155"/>
                 </a:solidFill>
               </a:rPr>
-              <a:t> 100% compliant custom CSS variables &amp; Flexbox.</a:t>
+              <a:t> Centralized `--primary`, `--dk`, and palette design tokens.</a:t>
             </a:r>
           </a:p>
           <a:p>
@@ -12409,7 +12393,7 @@
               </a:defRPr>
             </a:pPr>
             <a:r>
-              <a:t>ZERO FRAMEWORK DEPENDENCIES</a:t>
+              <a:t>RESPONSIVE GRID &amp; VARIABLES</a:t>
             </a:r>
           </a:p>
           <a:p>
@@ -12427,7 +12411,7 @@
                   <a:srgbClr val="0F172A"/>
                 </a:solidFill>
               </a:rPr>
-              <a:t>• Pure ES6+ JavaScript:</a:t>
+              <a:t>• CSS Grid &amp; Flexbox:</a:t>
             </a:r>
             <a:r>
               <a:rPr>
@@ -12435,7 +12419,7 @@
                   <a:srgbClr val="334155"/>
                 </a:solidFill>
               </a:rPr>
-              <a:t> Modular DOM controllers, async/await fetch.</a:t>
+              <a:t> Robust 2, 3, and 4-column layouts adapting seamlessly to viewport.</a:t>
             </a:r>
           </a:p>
           <a:p>
@@ -12453,7 +12437,7 @@
                   <a:srgbClr val="0F172A"/>
                 </a:solidFill>
               </a:rPr>
-              <a:t>• Zero Build Tools:</a:t>
+              <a:t>• Mobile-First Responsive:</a:t>
             </a:r>
             <a:r>
               <a:rPr>
@@ -12461,7 +12445,7 @@
                   <a:srgbClr val="334155"/>
                 </a:solidFill>
               </a:rPr>
-              <a:t> No node_modules, no webpack, no build steps required.</a:t>
+              <a:t> Fluid breakpoint system for smartphones, tablets, and laptops.</a:t>
             </a:r>
           </a:p>
           <a:p>
@@ -12479,7 +12463,7 @@
                   <a:srgbClr val="0F172A"/>
                 </a:solidFill>
               </a:rPr>
-              <a:t>• Official CDN Builds:</a:t>
+              <a:t>• Zero Framework Bloat:</a:t>
             </a:r>
             <a:r>
               <a:rPr>
@@ -12487,7 +12471,7 @@
                   <a:srgbClr val="334155"/>
                 </a:solidFill>
               </a:rPr>
-              <a:t> Supabase JS v2 &amp; Leaflet.js via CDN.</a:t>
+              <a:t> No Bootstrap, no Tailwind CSS; 100% custom lightweight styles.</a:t>
             </a:r>
           </a:p>
           <a:p>
@@ -12505,7 +12489,7 @@
                   <a:srgbClr val="0F172A"/>
                 </a:solidFill>
               </a:rPr>
-              <a:t>• Live Deployment:</a:t>
+              <a:t>• Smooth Hardware GPU Transitions:</a:t>
             </a:r>
             <a:r>
               <a:rPr>
@@ -12513,7 +12497,7 @@
                   <a:srgbClr val="334155"/>
                 </a:solidFill>
               </a:rPr>
-              <a:t> Hosted on Vercel Cloud (https://ecocycle-vanilla.vercel.app/).</a:t>
+              <a:t> Card hover elevations and modal animations.</a:t>
             </a:r>
           </a:p>
         </p:txBody>
@@ -12597,7 +12581,7 @@
               </a:defRPr>
             </a:pPr>
             <a:r>
-              <a:t>☁️ Shared Cloud BaaS</a:t>
+              <a:t>⚙️ Vanilla JS (ES6+)</a:t>
             </a:r>
             <a:r>
               <a:rPr b="1">
@@ -12605,7 +12589,7 @@
                   <a:srgbClr val="0F172A"/>
                 </a:solidFill>
               </a:rPr>
-              <a:t>• Single PostgreSQL DB:</a:t>
+              <a:t>• Modular Controllers:</a:t>
             </a:r>
             <a:r>
               <a:rPr>
@@ -12613,7 +12597,7 @@
                   <a:srgbClr val="334155"/>
                 </a:solidFill>
               </a:rPr>
-              <a:t> Shared schema across both React and Vanilla clients.</a:t>
+              <a:t> Dedicated scripts for `auth.js`, `pickups.js`, `map.js`, and `admin.js`.</a:t>
             </a:r>
           </a:p>
           <a:p>
@@ -12629,7 +12613,7 @@
               </a:defRPr>
             </a:pPr>
             <a:r>
-              <a:t>UNIFIED BACKEND &amp; STATE</a:t>
+              <a:t>MODULAR LOGIC &amp; ZERO BUILD TOOLS</a:t>
             </a:r>
           </a:p>
           <a:p>
@@ -12647,7 +12631,7 @@
                   <a:srgbClr val="0F172A"/>
                 </a:solidFill>
               </a:rPr>
-              <a:t>• Unified EmailJS:</a:t>
+              <a:t>• Native ES6+ APIs:</a:t>
             </a:r>
             <a:r>
               <a:rPr>
@@ -12655,7 +12639,7 @@
                   <a:srgbClr val="334155"/>
                 </a:solidFill>
               </a:rPr>
-              <a:t> Identical Service (`service_np1cnlg`) &amp; Template (`template_to9738m`).</a:t>
+              <a:t> Modern async/await, fetch, querySelector, and template strings.</a:t>
             </a:r>
           </a:p>
           <a:p>
@@ -12673,7 +12657,7 @@
                   <a:srgbClr val="0F172A"/>
                 </a:solidFill>
               </a:rPr>
-              <a:t>• Row Level Security (RLS):</a:t>
+              <a:t>• Zero Build Tools:</a:t>
             </a:r>
             <a:r>
               <a:rPr>
@@ -12681,7 +12665,7 @@
                   <a:srgbClr val="334155"/>
                 </a:solidFill>
               </a:rPr>
-              <a:t> Database-level access control enforced for both.</a:t>
+              <a:t> No node_modules folder, no bundlers, zero maintenance debt.</a:t>
             </a:r>
           </a:p>
           <a:p>
@@ -12699,7 +12683,7 @@
                   <a:srgbClr val="0F172A"/>
                 </a:solidFill>
               </a:rPr>
-              <a:t>• Cross-Platform Parity:</a:t>
+              <a:t>• Official CDN Builds:</a:t>
             </a:r>
             <a:r>
               <a:rPr>
@@ -12707,7 +12691,7 @@
                   <a:srgbClr val="334155"/>
                 </a:solidFill>
               </a:rPr>
-              <a:t> Action taken in React displays immediately in Vanilla.</a:t>
+              <a:t> Official Supabase JS v2, Leaflet GIS, and EmailJS browser SDK.</a:t>
             </a:r>
           </a:p>
           <a:p>
@@ -12725,7 +12709,7 @@
                   <a:srgbClr val="0F172A"/>
                 </a:solidFill>
               </a:rPr>
-              <a:t>• Architectural Advantage:</a:t>
+              <a:t>• Edge Hosted:</a:t>
             </a:r>
             <a:r>
               <a:rPr>
@@ -12733,7 +12717,7 @@
                   <a:srgbClr val="334155"/>
                 </a:solidFill>
               </a:rPr>
-              <a:t> Demonstrates deep mastery of foundational web standards &amp; modern frameworks.</a:t>
+              <a:t> Instant production deploys on Vercel Edge and GitHub Pages.</a:t>
             </a:r>
           </a:p>
         </p:txBody>
@@ -13123,7 +13107,7 @@
                   <a:srgbClr val="334155"/>
                 </a:solidFill>
               </a:rPr>
-              <a:t>• React Single Page Application (Vite Bundler, Tailwind Utility CSS, Lucide Icons)</a:t>
+              <a:t>• Pure Vanilla Web Architecture (8 Semantic HTML5 Pages, Custom Responsive CSS3)</a:t>
             </a:r>
           </a:p>
           <a:p>
@@ -13141,7 +13125,7 @@
                   <a:srgbClr val="334155"/>
                 </a:solidFill>
               </a:rPr>
-              <a:t>• Pure Vanilla Web Platform (Custom CSS3 Flexbox/Grid, ES6+ Controllers)</a:t>
+              <a:t>• Modular ES6+ JavaScript Controllers (auth.js, pickups.js, map.js, admin.js)</a:t>
             </a:r>
           </a:p>
           <a:p>
@@ -13819,7 +13803,7 @@
                   <a:srgbClr val="334155"/>
                 </a:solidFill>
               </a:rPr>
-              <a:t>• Vercel Cloud Edge Network (Both React &amp; Vanilla Editions)</a:t>
+              <a:t>• Vercel Cloud Edge Network &amp; GitHub Pages Global Static Hosting</a:t>
             </a:r>
           </a:p>
         </p:txBody>

</xml_diff>

<commit_message>
docs(presentation): update presentation for general delivery with both React and Vanilla live sites
</commit_message>
<xml_diff>
--- a/EcoCycle_Project_Presentation.pptx
+++ b/EcoCycle_Project_Presentation.pptx
@@ -4607,7 +4607,7 @@
                   <a:srgbClr val="0F172A"/>
                 </a:solidFill>
               </a:rPr>
-              <a:t>• Direct Client Dispatch:</a:t>
+              <a:t>• Shared Client Pipeline:</a:t>
             </a:r>
             <a:r>
               <a:rPr>
@@ -4615,7 +4615,7 @@
                   <a:srgbClr val="334155"/>
                 </a:solidFill>
               </a:rPr>
-              <a:t> Pre-configured service (`service_np1cnlg`) and template (`template_to9738m`) dispatching securely from the browser.</a:t>
+              <a:t> Pre-configured service (`service_np1cnlg`) and template (`template_to9738m`) dispatching uniformly across both React and Vanilla editions.</a:t>
             </a:r>
           </a:p>
           <a:p>
@@ -5177,7 +5177,7 @@
               </a:defRPr>
             </a:pPr>
             <a:r>
-              <a:t>Live Cloud Deployments &amp; Empirical Validation</a:t>
+              <a:t>Live Cloud Deployments &amp; Cross-Platform Parity</a:t>
             </a:r>
           </a:p>
         </p:txBody>
@@ -5213,7 +5213,7 @@
               </a:defRPr>
             </a:pPr>
             <a:r>
-              <a:t>Zero-build vanilla web architecture verified and live on public cloud endpoints</a:t>
+              <a:t>Both editions successfully tested, cloud-hosted, and live on production endpoints</a:t>
             </a:r>
           </a:p>
         </p:txBody>
@@ -5291,13 +5291,13 @@
               </a:spcAft>
               <a:defRPr sz="1100" b="1">
                 <a:solidFill>
-                  <a:srgbClr val="10A34A"/>
-                </a:solidFill>
-                <a:latin typeface="Segoe UI"/>
-              </a:defRPr>
-            </a:pPr>
-            <a:r>
-              <a:t>🌿 Primary: Vercel Cloud Edge</a:t>
+                  <a:srgbClr val="0EA5E9"/>
+                </a:solidFill>
+                <a:latin typeface="Segoe UI"/>
+              </a:defRPr>
+            </a:pPr>
+            <a:r>
+              <a:t>⚛️ Edition 1: React 18 Modern SPA</a:t>
             </a:r>
             <a:r>
               <a:rPr b="1">
@@ -5313,7 +5313,7 @@
                   <a:srgbClr val="334155"/>
                 </a:solidFill>
               </a:rPr>
-              <a:t> https://ecocycle-vanilla.vercel.app/</a:t>
+              <a:t> https://ecocycle-beryl.vercel.app/</a:t>
             </a:r>
           </a:p>
           <a:p>
@@ -5329,7 +5329,7 @@
               </a:defRPr>
             </a:pPr>
             <a:r>
-              <a:t>PRODUCTION EDGE NETWORK</a:t>
+              <a:t>HOSTED ON VERCEL GLOBAL EDGE</a:t>
             </a:r>
           </a:p>
           <a:p>
@@ -5347,7 +5347,7 @@
                   <a:srgbClr val="0F172A"/>
                 </a:solidFill>
               </a:rPr>
-              <a:t>• Continuous Deployment:</a:t>
+              <a:t>• Source Repository:</a:t>
             </a:r>
             <a:r>
               <a:rPr>
@@ -5355,7 +5355,7 @@
                   <a:srgbClr val="334155"/>
                 </a:solidFill>
               </a:rPr>
-              <a:t> Automated CI/CD pipeline linked to GitHub `main`.</a:t>
+              <a:t> https://github.com/chandan-bk/ecocycle</a:t>
             </a:r>
           </a:p>
           <a:p>
@@ -5373,7 +5373,7 @@
                   <a:srgbClr val="334155"/>
                 </a:solidFill>
               </a:rPr>
-              <a:t>• Lighthouse Score: 99/100 performance; First Contentful Paint &lt; 0.4s.</a:t>
+              <a:t>• Lighthouse Performance: 98/100; First Contentful Paint &lt; 0.8s.</a:t>
             </a:r>
           </a:p>
           <a:p>
@@ -5391,7 +5391,7 @@
                   <a:srgbClr val="334155"/>
                 </a:solidFill>
               </a:rPr>
-              <a:t>• Instant global edge caching with SSL/TLS encryption by default.</a:t>
+              <a:t>• Component-driven SPA with real-time Supabase Auth state guards.</a:t>
             </a:r>
           </a:p>
         </p:txBody>
@@ -5469,13 +5469,13 @@
               </a:spcAft>
               <a:defRPr sz="1100" b="1">
                 <a:solidFill>
-                  <a:srgbClr val="0D9488"/>
-                </a:solidFill>
-                <a:latin typeface="Segoe UI"/>
-              </a:defRPr>
-            </a:pPr>
-            <a:r>
-              <a:t>🌐 Mirror: GitHub Pages Static Host</a:t>
+                  <a:srgbClr val="10A34A"/>
+                </a:solidFill>
+                <a:latin typeface="Segoe UI"/>
+              </a:defRPr>
+            </a:pPr>
+            <a:r>
+              <a:t>🌿 Edition 2: Pure Vanilla Web Platform</a:t>
             </a:r>
             <a:r>
               <a:rPr b="1">
@@ -5483,7 +5483,7 @@
                   <a:srgbClr val="0F172A"/>
                 </a:solidFill>
               </a:rPr>
-              <a:t>• Live Mirror URL:</a:t>
+              <a:t>• Live Production URL:</a:t>
             </a:r>
             <a:r>
               <a:rPr>
@@ -5491,28 +5491,54 @@
                   <a:srgbClr val="334155"/>
                 </a:solidFill>
               </a:rPr>
+              <a:t> https://ecocycle-vanilla.vercel.app/</a:t>
+            </a:r>
+          </a:p>
+          <a:p>
+            <a:pPr>
+              <a:spcAft>
+                <a:spcPts val="800"/>
+              </a:spcAft>
+              <a:defRPr sz="1000" b="1">
+                <a:solidFill>
+                  <a:srgbClr val="475569"/>
+                </a:solidFill>
+                <a:latin typeface="Segoe UI"/>
+              </a:defRPr>
+            </a:pPr>
+            <a:r>
+              <a:t>HOSTED ON VERCEL &amp; GITHUB PAGES</a:t>
+            </a:r>
+          </a:p>
+          <a:p>
+            <a:pPr>
+              <a:spcAft>
+                <a:spcPts val="400"/>
+              </a:spcAft>
+              <a:defRPr sz="1100">
+                <a:latin typeface="Segoe UI"/>
+              </a:defRPr>
+            </a:pPr>
+            <a:r>
+              <a:rPr b="1">
+                <a:solidFill>
+                  <a:srgbClr val="0F172A"/>
+                </a:solidFill>
+              </a:rPr>
+              <a:t>• Live Static Mirror:</a:t>
+            </a:r>
+            <a:r>
+              <a:rPr>
+                <a:solidFill>
+                  <a:srgbClr val="334155"/>
+                </a:solidFill>
+              </a:rPr>
               <a:t> https://chandan-bk.github.io/ecocycle-vanilla/</a:t>
             </a:r>
           </a:p>
           <a:p>
             <a:pPr>
               <a:spcAft>
-                <a:spcPts val="800"/>
-              </a:spcAft>
-              <a:defRPr sz="1000" b="1">
-                <a:solidFill>
-                  <a:srgbClr val="475569"/>
-                </a:solidFill>
-                <a:latin typeface="Segoe UI"/>
-              </a:defRPr>
-            </a:pPr>
-            <a:r>
-              <a:t>HIGH-AVAILABILITY CLOUD MIRROR</a:t>
-            </a:r>
-          </a:p>
-          <a:p>
-            <a:pPr>
-              <a:spcAft>
                 <a:spcPts val="400"/>
               </a:spcAft>
               <a:defRPr sz="1100">
@@ -5551,25 +5577,7 @@
                   <a:srgbClr val="334155"/>
                 </a:solidFill>
               </a:rPr>
-              <a:t>• Zero build tools; native browser static file serving directly from Git.</a:t>
-            </a:r>
-          </a:p>
-          <a:p>
-            <a:pPr>
-              <a:spcAft>
-                <a:spcPts val="400"/>
-              </a:spcAft>
-              <a:defRPr sz="1100">
-                <a:latin typeface="Segoe UI"/>
-              </a:defRPr>
-            </a:pPr>
-            <a:r>
-              <a:rPr>
-                <a:solidFill>
-                  <a:srgbClr val="334155"/>
-                </a:solidFill>
-              </a:rPr>
-              <a:t>• Full client functionality: Supabase Auth, Leaflet GIS, and EmailJS alerts.</a:t>
+              <a:t>• Zero build tools; instant native edge rendering with unified DB parity.</a:t>
             </a:r>
           </a:p>
         </p:txBody>
@@ -5669,7 +5677,7 @@
                   <a:srgbClr val="334155"/>
                 </a:solidFill>
               </a:rPr>
-              <a:t> User schedules pickup in web portal -&gt; Confirmed in DB -&gt; Instant Email receipt received -&gt; Visible in 'My Pickups'. [PASSED]</a:t>
+              <a:t> User schedules pickup in Vanilla web -&gt; Confirmed in DB -&gt; Instant Email receipt received -&gt; Visible in React 'My Pickups'. [PASSED]</a:t>
             </a:r>
           </a:p>
           <a:p>
@@ -5695,7 +5703,7 @@
                   <a:srgbClr val="334155"/>
                 </a:solidFill>
               </a:rPr>
-              <a:t> Status changed to 'collected' in Admin portal -&gt; Triggered status email alert -&gt; Updated Impact analytics. [PASSED]</a:t>
+              <a:t> Status changed to 'collected' in Admin portal -&gt; Triggered status email alert -&gt; Updated Impact analytics on both. [PASSED]</a:t>
             </a:r>
           </a:p>
           <a:p>
@@ -7069,7 +7077,7 @@
                   <a:srgbClr val="334155"/>
                 </a:solidFill>
               </a:rPr>
-              <a:t>• Proved that enterprise-grade cloud applications can be built with pure HTML5, CSS3, and ES6+.</a:t>
+              <a:t>• Demonstrated competence in both modern reactive frameworks (React + Vite) and pure web standards (HTML5/CSS3/ES6+).</a:t>
             </a:r>
           </a:p>
           <a:p>
@@ -7085,7 +7093,7 @@
               </a:defRPr>
             </a:pPr>
             <a:r>
-              <a:t>PURE VANILLA ENGINEERING</a:t>
+              <a:t>DUAL-STACK ENGINEERING</a:t>
             </a:r>
           </a:p>
           <a:p>
@@ -7103,7 +7111,7 @@
                   <a:srgbClr val="334155"/>
                 </a:solidFill>
               </a:rPr>
-              <a:t>• Eliminated build-tool complexity (zero node_modules, zero bundlers, instant execution).</a:t>
+              <a:t>• Proved that both architectures achieve 100% operational parity sharing a single Supabase backend.</a:t>
             </a:r>
           </a:p>
           <a:p>
@@ -7121,7 +7129,7 @@
                   <a:srgbClr val="334155"/>
                 </a:solidFill>
               </a:rPr>
-              <a:t>• Leveraged BaaS (Supabase) to eliminate backend infrastructure management while enforcing RLS.</a:t>
+              <a:t>• Leveraged BaaS to eliminate backend infrastructure management while enforcing strict RLS.</a:t>
             </a:r>
           </a:p>
         </p:txBody>
@@ -7290,7 +7298,7 @@
                   <a:srgbClr val="334155"/>
                 </a:solidFill>
               </a:rPr>
-              <a:t>• Architected a serverless transactional email pipeline delivering live alerts.</a:t>
+              <a:t>• Architected a serverless transactional email pipeline delivering live alerts in &lt; 2.5s.</a:t>
             </a:r>
           </a:p>
           <a:p>
@@ -7308,7 +7316,7 @@
                   <a:srgbClr val="334155"/>
                 </a:solidFill>
               </a:rPr>
-              <a:t>• Platform successfully deployed and validated on public production URLs (Vercel &amp; GitHub Pages).</a:t>
+              <a:t>• Both platforms successfully deployed and validated on public production edge endpoints.</a:t>
             </a:r>
           </a:p>
         </p:txBody>
@@ -7518,7 +7526,7 @@
               </a:defRPr>
             </a:pPr>
             <a:r>
-              <a:t>🌿 Production Web App (Vercel):  https://ecocycle-vanilla.vercel.app/</a:t>
+              <a:t>🌿 Vanilla Edition Live Demo:   https://ecocycle-vanilla.vercel.app/</a:t>
             </a:r>
           </a:p>
           <a:p>
@@ -7534,7 +7542,7 @@
               </a:defRPr>
             </a:pPr>
             <a:r>
-              <a:t>🌐 Live Static Mirror (GitHub):  https://chandan-bk.github.io/ecocycle-vanilla/</a:t>
+              <a:t>⚛️ React Edition Live Demo:     https://ecocycle-beryl.vercel.app/</a:t>
             </a:r>
           </a:p>
           <a:p>
@@ -7550,7 +7558,7 @@
               </a:defRPr>
             </a:pPr>
             <a:r>
-              <a:t>📦 Source Code (GitHub):        https://github.com/chandan-bk/ecocycle-vanilla</a:t>
+              <a:t>🌐 GitHub Pages Live Mirror:    https://chandan-bk.github.io/ecocycle-vanilla/</a:t>
             </a:r>
           </a:p>
           <a:p>
@@ -7566,7 +7574,7 @@
               </a:defRPr>
             </a:pPr>
             <a:r>
-              <a:t>🗄️ Supabase Cloud Database:      https://anusmzkuuudrtgzgccby.supabase.co</a:t>
+              <a:t>📦 Vanilla GitHub Repository:   https://github.com/chandan-bk/ecocycle-vanilla</a:t>
             </a:r>
           </a:p>
           <a:p>
@@ -7582,7 +7590,7 @@
               </a:defRPr>
             </a:pPr>
             <a:r>
-              <a:t>✉️ EmailJS Notification Engine:  service_np1cnlg (template_to9738m)</a:t>
+              <a:t>📦 React GitHub Repository:     https://github.com/chandan-bk/ecocycle</a:t>
             </a:r>
           </a:p>
           <a:p>
@@ -7598,7 +7606,39 @@
               </a:defRPr>
             </a:pPr>
             <a:r>
-              <a:t>👥 Team Members (PESCE CSE):     Chandan B K, Dhanush Gowda R, Dore Prasad C K, Gowri Shankar S</a:t>
+              <a:t>🗄️ Supabase Cloud DB Host:      https://anusmzkuuudrtgzgccby.supabase.co</a:t>
+            </a:r>
+          </a:p>
+          <a:p>
+            <a:pPr>
+              <a:spcAft>
+                <a:spcPts val="400"/>
+              </a:spcAft>
+              <a:defRPr sz="1200">
+                <a:solidFill>
+                  <a:srgbClr val="F1F5F9"/>
+                </a:solidFill>
+                <a:latin typeface="Consolas"/>
+              </a:defRPr>
+            </a:pPr>
+            <a:r>
+              <a:t>✉️ EmailJS Service Engine:      service_np1cnlg (template_to9738m)</a:t>
+            </a:r>
+          </a:p>
+          <a:p>
+            <a:pPr>
+              <a:spcAft>
+                <a:spcPts val="400"/>
+              </a:spcAft>
+              <a:defRPr sz="1200">
+                <a:solidFill>
+                  <a:srgbClr val="F1F5F9"/>
+                </a:solidFill>
+                <a:latin typeface="Consolas"/>
+              </a:defRPr>
+            </a:pPr>
+            <a:r>
+              <a:t>👥 Project Team (PESCE CSE):    Chandan B K, Dhanush Gowda R, Dore Prasad C K, Gowri Shankar S</a:t>
             </a:r>
           </a:p>
         </p:txBody>
@@ -8153,7 +8193,7 @@
                   <a:srgbClr val="334155"/>
                 </a:solidFill>
               </a:rPr>
-              <a:t>• Modular Vanilla ES6+ State &amp; Session Synchronization</a:t>
+              <a:t>• Dual-Platform Architecture (React SPA &amp; Pure Vanilla Web)</a:t>
             </a:r>
           </a:p>
         </p:txBody>
@@ -11985,7 +12025,7 @@
               </a:defRPr>
             </a:pPr>
             <a:r>
-              <a:t>FRONTEND ENGINEERING</a:t>
+              <a:t>ARCHITECTURAL INNOVATION</a:t>
             </a:r>
           </a:p>
         </p:txBody>
@@ -12021,7 +12061,7 @@
               </a:defRPr>
             </a:pPr>
             <a:r>
-              <a:t>Pure Vanilla Web Architecture: Zero-Framework Mastery</a:t>
+              <a:t>Dual-Implementation Strategy: Modern React &amp; Pure Vanilla Web</a:t>
             </a:r>
           </a:p>
         </p:txBody>
@@ -12057,7 +12097,7 @@
               </a:defRPr>
             </a:pPr>
             <a:r>
-              <a:t>High performance, zero build overhead, and maximum web standards compliance</a:t>
+              <a:t>Full functional parity across modern component frameworks and zero-dependency web standards</a:t>
             </a:r>
           </a:p>
         </p:txBody>
@@ -12135,13 +12175,13 @@
               </a:spcAft>
               <a:defRPr sz="1200" b="1">
                 <a:solidFill>
-                  <a:srgbClr val="064E3B"/>
-                </a:solidFill>
-                <a:latin typeface="Segoe UI"/>
-              </a:defRPr>
-            </a:pPr>
-            <a:r>
-              <a:t>🌐 HTML5 Semantic Core</a:t>
+                  <a:srgbClr val="0EA5E9"/>
+                </a:solidFill>
+                <a:latin typeface="Segoe UI"/>
+              </a:defRPr>
+            </a:pPr>
+            <a:r>
+              <a:t>⚛️ React 18 Modern SPA</a:t>
             </a:r>
             <a:r>
               <a:rPr b="1">
@@ -12149,7 +12189,7 @@
                   <a:srgbClr val="0F172A"/>
                 </a:solidFill>
               </a:rPr>
-              <a:t>• 8 Semantic Pages:</a:t>
+              <a:t>• React 18 &amp; Vite:</a:t>
             </a:r>
             <a:r>
               <a:rPr>
@@ -12157,7 +12197,7 @@
                   <a:srgbClr val="334155"/>
                 </a:solidFill>
               </a:rPr>
-              <a:t> Dedicated views for Locator, Pickup, Tracking, Quiz, Analytics, and Admin.</a:t>
+              <a:t> Ultra-fast HMR and optimized asset bundling.</a:t>
             </a:r>
           </a:p>
           <a:p>
@@ -12173,7 +12213,7 @@
               </a:defRPr>
             </a:pPr>
             <a:r>
-              <a:t>ACCESSIBLE &amp; MODULAR MARKUP</a:t>
+              <a:t>COMPONENT ARCHITECTURE</a:t>
             </a:r>
           </a:p>
           <a:p>
@@ -12191,7 +12231,7 @@
                   <a:srgbClr val="0F172A"/>
                 </a:solidFill>
               </a:rPr>
-              <a:t>• Native Validation:</a:t>
+              <a:t>• Tailwind CSS:</a:t>
             </a:r>
             <a:r>
               <a:rPr>
@@ -12199,7 +12239,7 @@
                   <a:srgbClr val="334155"/>
                 </a:solidFill>
               </a:rPr>
-              <a:t> HTML5 constraint validation for dates, email addresses, and quantities.</a:t>
+              <a:t> Modern utility-first styling with accessible responsive layout.</a:t>
             </a:r>
           </a:p>
           <a:p>
@@ -12217,7 +12257,7 @@
                   <a:srgbClr val="0F172A"/>
                 </a:solidFill>
               </a:rPr>
-              <a:t>• Accessible Landmarks:</a:t>
+              <a:t>• Lucide React:</a:t>
             </a:r>
             <a:r>
               <a:rPr>
@@ -12225,7 +12265,7 @@
                   <a:srgbClr val="334155"/>
                 </a:solidFill>
               </a:rPr>
-              <a:t> Built with `&lt;main&gt;`, `&lt;nav&gt;`, `&lt;header&gt;`, `&lt;footer&gt;`, and `&lt;section&gt;` tags.</a:t>
+              <a:t> Consistent SVG iconography across all components.</a:t>
             </a:r>
           </a:p>
           <a:p>
@@ -12243,7 +12283,7 @@
                   <a:srgbClr val="0F172A"/>
                 </a:solidFill>
               </a:rPr>
-              <a:t>• Fastest First Paint:</a:t>
+              <a:t>• Client Routing:</a:t>
             </a:r>
             <a:r>
               <a:rPr>
@@ -12251,7 +12291,7 @@
                   <a:srgbClr val="334155"/>
                 </a:solidFill>
               </a:rPr>
-              <a:t> Zero virtual DOM diffing; browser renders HTML directly on arrival.</a:t>
+              <a:t> Single Page Application (SPA) client-side routes.</a:t>
             </a:r>
           </a:p>
           <a:p>
@@ -12269,7 +12309,7 @@
                   <a:srgbClr val="0F172A"/>
                 </a:solidFill>
               </a:rPr>
-              <a:t>• Zero Transpilation:</a:t>
+              <a:t>• Live Production:</a:t>
             </a:r>
             <a:r>
               <a:rPr>
@@ -12277,7 +12317,7 @@
                   <a:srgbClr val="334155"/>
                 </a:solidFill>
               </a:rPr>
-              <a:t> Works instantly across modern desktop and mobile browsers.</a:t>
+              <a:t> Hosted on Vercel Global Edge CDN.</a:t>
             </a:r>
           </a:p>
         </p:txBody>
@@ -12361,7 +12401,7 @@
               </a:defRPr>
             </a:pPr>
             <a:r>
-              <a:t>🎨 Custom CSS3 System</a:t>
+              <a:t>🌿 Pure Vanilla Edition</a:t>
             </a:r>
             <a:r>
               <a:rPr b="1">
@@ -12369,7 +12409,7 @@
                   <a:srgbClr val="0F172A"/>
                 </a:solidFill>
               </a:rPr>
-              <a:t>• CSS Custom Properties:</a:t>
+              <a:t>• 8 HTML5 Semantic Pages:</a:t>
             </a:r>
             <a:r>
               <a:rPr>
@@ -12377,7 +12417,7 @@
                   <a:srgbClr val="334155"/>
                 </a:solidFill>
               </a:rPr>
-              <a:t> Centralized `--primary`, `--dk`, and palette design tokens.</a:t>
+              <a:t> Dedicated views for Locator, Pickups, Admin, Quiz.</a:t>
             </a:r>
           </a:p>
           <a:p>
@@ -12393,7 +12433,7 @@
               </a:defRPr>
             </a:pPr>
             <a:r>
-              <a:t>RESPONSIVE GRID &amp; VARIABLES</a:t>
+              <a:t>ZERO FRAMEWORK DEPENDENCIES</a:t>
             </a:r>
           </a:p>
           <a:p>
@@ -12411,7 +12451,7 @@
                   <a:srgbClr val="0F172A"/>
                 </a:solidFill>
               </a:rPr>
-              <a:t>• CSS Grid &amp; Flexbox:</a:t>
+              <a:t>• Custom CSS3 Variables:</a:t>
             </a:r>
             <a:r>
               <a:rPr>
@@ -12419,7 +12459,7 @@
                   <a:srgbClr val="334155"/>
                 </a:solidFill>
               </a:rPr>
-              <a:t> Robust 2, 3, and 4-column layouts adapting seamlessly to viewport.</a:t>
+              <a:t> Centralized design tokens and fluid grid layout.</a:t>
             </a:r>
           </a:p>
           <a:p>
@@ -12437,7 +12477,7 @@
                   <a:srgbClr val="0F172A"/>
                 </a:solidFill>
               </a:rPr>
-              <a:t>• Mobile-First Responsive:</a:t>
+              <a:t>• Vanilla ES6+ JS:</a:t>
             </a:r>
             <a:r>
               <a:rPr>
@@ -12445,7 +12485,7 @@
                   <a:srgbClr val="334155"/>
                 </a:solidFill>
               </a:rPr>
-              <a:t> Fluid breakpoint system for smartphones, tablets, and laptops.</a:t>
+              <a:t> Native async/await, modular DOM controllers.</a:t>
             </a:r>
           </a:p>
           <a:p>
@@ -12463,7 +12503,7 @@
                   <a:srgbClr val="0F172A"/>
                 </a:solidFill>
               </a:rPr>
-              <a:t>• Zero Framework Bloat:</a:t>
+              <a:t>• Zero Build Overhead:</a:t>
             </a:r>
             <a:r>
               <a:rPr>
@@ -12471,7 +12511,7 @@
                   <a:srgbClr val="334155"/>
                 </a:solidFill>
               </a:rPr>
-              <a:t> No Bootstrap, no Tailwind CSS; 100% custom lightweight styles.</a:t>
+              <a:t> No node_modules, no bundlers, zero maintenance debt.</a:t>
             </a:r>
           </a:p>
           <a:p>
@@ -12489,7 +12529,7 @@
                   <a:srgbClr val="0F172A"/>
                 </a:solidFill>
               </a:rPr>
-              <a:t>• Smooth Hardware GPU Transitions:</a:t>
+              <a:t>• Live Deployment:</a:t>
             </a:r>
             <a:r>
               <a:rPr>
@@ -12497,7 +12537,7 @@
                   <a:srgbClr val="334155"/>
                 </a:solidFill>
               </a:rPr>
-              <a:t> Card hover elevations and modal animations.</a:t>
+              <a:t> Hosted on Vercel Edge &amp; GitHub Pages.</a:t>
             </a:r>
           </a:p>
         </p:txBody>
@@ -12581,7 +12621,7 @@
               </a:defRPr>
             </a:pPr>
             <a:r>
-              <a:t>⚙️ Vanilla JS (ES6+)</a:t>
+              <a:t>☁️ Shared Cloud BaaS</a:t>
             </a:r>
             <a:r>
               <a:rPr b="1">
@@ -12589,7 +12629,7 @@
                   <a:srgbClr val="0F172A"/>
                 </a:solidFill>
               </a:rPr>
-              <a:t>• Modular Controllers:</a:t>
+              <a:t>• Single PostgreSQL DB:</a:t>
             </a:r>
             <a:r>
               <a:rPr>
@@ -12597,7 +12637,7 @@
                   <a:srgbClr val="334155"/>
                 </a:solidFill>
               </a:rPr>
-              <a:t> Dedicated scripts for `auth.js`, `pickups.js`, `map.js`, and `admin.js`.</a:t>
+              <a:t> Shared schema across React and Vanilla frontends.</a:t>
             </a:r>
           </a:p>
           <a:p>
@@ -12613,7 +12653,7 @@
               </a:defRPr>
             </a:pPr>
             <a:r>
-              <a:t>MODULAR LOGIC &amp; ZERO BUILD TOOLS</a:t>
+              <a:t>UNIFIED BACKEND &amp; STATE</a:t>
             </a:r>
           </a:p>
           <a:p>
@@ -12631,7 +12671,7 @@
                   <a:srgbClr val="0F172A"/>
                 </a:solidFill>
               </a:rPr>
-              <a:t>• Native ES6+ APIs:</a:t>
+              <a:t>• Unified EmailJS:</a:t>
             </a:r>
             <a:r>
               <a:rPr>
@@ -12639,7 +12679,7 @@
                   <a:srgbClr val="334155"/>
                 </a:solidFill>
               </a:rPr>
-              <a:t> Modern async/await, fetch, querySelector, and template strings.</a:t>
+              <a:t> Identical Service (`service_np1cnlg`) &amp; Template (`template_to9738m`).</a:t>
             </a:r>
           </a:p>
           <a:p>
@@ -12657,7 +12697,7 @@
                   <a:srgbClr val="0F172A"/>
                 </a:solidFill>
               </a:rPr>
-              <a:t>• Zero Build Tools:</a:t>
+              <a:t>• Row Level Security (RLS):</a:t>
             </a:r>
             <a:r>
               <a:rPr>
@@ -12665,7 +12705,7 @@
                   <a:srgbClr val="334155"/>
                 </a:solidFill>
               </a:rPr>
-              <a:t> No node_modules folder, no bundlers, zero maintenance debt.</a:t>
+              <a:t> Database-level access control enforced for both.</a:t>
             </a:r>
           </a:p>
           <a:p>
@@ -12683,7 +12723,7 @@
                   <a:srgbClr val="0F172A"/>
                 </a:solidFill>
               </a:rPr>
-              <a:t>• Official CDN Builds:</a:t>
+              <a:t>• Live State Parity:</a:t>
             </a:r>
             <a:r>
               <a:rPr>
@@ -12691,7 +12731,7 @@
                   <a:srgbClr val="334155"/>
                 </a:solidFill>
               </a:rPr>
-              <a:t> Official Supabase JS v2, Leaflet GIS, and EmailJS browser SDK.</a:t>
+              <a:t> Action taken in React reflects instantly in Vanilla.</a:t>
             </a:r>
           </a:p>
           <a:p>
@@ -12709,7 +12749,7 @@
                   <a:srgbClr val="0F172A"/>
                 </a:solidFill>
               </a:rPr>
-              <a:t>• Edge Hosted:</a:t>
+              <a:t>• Engineering Mastery:</a:t>
             </a:r>
             <a:r>
               <a:rPr>
@@ -12717,7 +12757,7 @@
                   <a:srgbClr val="334155"/>
                 </a:solidFill>
               </a:rPr>
-              <a:t> Instant production deploys on Vercel Edge and GitHub Pages.</a:t>
+              <a:t> Proves deep versatility across frameworks and native web standards.</a:t>
             </a:r>
           </a:p>
         </p:txBody>
@@ -13107,7 +13147,7 @@
                   <a:srgbClr val="334155"/>
                 </a:solidFill>
               </a:rPr>
-              <a:t>• Pure Vanilla Web Architecture (8 Semantic HTML5 Pages, Custom Responsive CSS3)</a:t>
+              <a:t>• Dual Frontend Clients: Modern React 18 SPA &amp; Pure Vanilla Web (8 Pages)</a:t>
             </a:r>
           </a:p>
           <a:p>
@@ -13125,7 +13165,7 @@
                   <a:srgbClr val="334155"/>
                 </a:solidFill>
               </a:rPr>
-              <a:t>• Modular ES6+ JavaScript Controllers (auth.js, pickups.js, map.js, admin.js)</a:t>
+              <a:t>• Custom CSS3 Grid/Flexbox &amp; Tailwind CSS utility styling systems</a:t>
             </a:r>
           </a:p>
           <a:p>
@@ -13803,7 +13843,7 @@
                   <a:srgbClr val="334155"/>
                 </a:solidFill>
               </a:rPr>
-              <a:t>• Vercel Cloud Edge Network &amp; GitHub Pages Global Static Hosting</a:t>
+              <a:t>• Vercel Cloud Edge Network (Hosting Both React &amp; Vanilla) + GitHub Pages</a:t>
             </a:r>
           </a:p>
         </p:txBody>

</xml_diff>

<commit_message>
feat: upgrade vanilla UI with Lucide SVG vector icons, align presentation graphics, and update academic level to 3rd Sem
</commit_message>
<xml_diff>
--- a/EcoCycle_Project_Presentation.pptx
+++ b/EcoCycle_Project_Presentation.pptx
@@ -3399,7 +3399,7 @@
               </a:defRPr>
             </a:pPr>
             <a:r>
-              <a:t>• Chandan B K  (Lead Architect · 2nd Sem CSE)</a:t>
+              <a:t>• Chandan B K  (Lead Architect · 3rd Sem CSE)</a:t>
             </a:r>
           </a:p>
           <a:p>
@@ -3415,7 +3415,7 @@
               </a:defRPr>
             </a:pPr>
             <a:r>
-              <a:t>• Dhanush Gowda R  (Frontend &amp; Leaflet GIS · 2nd Sem CSE)</a:t>
+              <a:t>• Dhanush Gowda R  (Frontend &amp; Leaflet GIS · 3rd Sem CSE)</a:t>
             </a:r>
           </a:p>
           <a:p>
@@ -3431,7 +3431,7 @@
               </a:defRPr>
             </a:pPr>
             <a:r>
-              <a:t>• Dore Prasad C K  (Backend &amp; EmailJS Systems · 2nd Sem CSE)</a:t>
+              <a:t>• Dore Prasad C K  (Backend &amp; EmailJS Systems · 3rd Sem CSE)</a:t>
             </a:r>
           </a:p>
           <a:p>
@@ -3447,7 +3447,7 @@
               </a:defRPr>
             </a:pPr>
             <a:r>
-              <a:t>• Gowri Shankar S  (Data Analytics &amp; QA · 2nd Sem CSE)</a:t>
+              <a:t>• Gowri Shankar S  (Data Analytics &amp; QA · 3rd Sem CSE)</a:t>
             </a:r>
           </a:p>
         </p:txBody>
@@ -8006,7 +8006,7 @@
               </a:defRPr>
             </a:pPr>
             <a:r>
-              <a:t>Lead &amp; Full-Stack Architect (2nd Sem CSE · PESCE)</a:t>
+              <a:t>Lead &amp; Full-Stack Architect (3rd Sem CSE · PESCE)</a:t>
             </a:r>
           </a:p>
           <a:p>
@@ -8349,7 +8349,7 @@
               </a:defRPr>
             </a:pPr>
             <a:r>
-              <a:t>Frontend &amp; Leaflet GIS (2nd Sem CSE · PESCE)</a:t>
+              <a:t>Frontend &amp; Leaflet GIS (3rd Sem CSE · PESCE)</a:t>
             </a:r>
           </a:p>
           <a:p>
@@ -8692,7 +8692,7 @@
               </a:defRPr>
             </a:pPr>
             <a:r>
-              <a:t>Backend &amp; EmailJS Systems (2nd Sem CSE · PESCE)</a:t>
+              <a:t>Backend &amp; EmailJS Systems (3rd Sem CSE · PESCE)</a:t>
             </a:r>
           </a:p>
           <a:p>
@@ -9035,7 +9035,7 @@
               </a:defRPr>
             </a:pPr>
             <a:r>
-              <a:t>Analytics &amp; QA Modeler (2nd Sem CSE · PESCE)</a:t>
+              <a:t>Analytics &amp; QA Modeler (3rd Sem CSE · PESCE)</a:t>
             </a:r>
           </a:p>
           <a:p>

</xml_diff>